<commit_message>
Done my part for the presentation.
</commit_message>
<xml_diff>
--- a/presentation/Presentation.pptx
+++ b/presentation/Presentation.pptx
@@ -384,7 +384,7 @@
                 <a:uFillTx/>
                 <a:latin typeface="Calibri"/>
               </a:rPr>
-              <a:t> </a:t>
+              <a:t>&lt;date/time&gt;</a:t>
             </a:r>
             <a:endParaRPr lang="en-US" sz="1200" b="0" u="none" strike="noStrike">
               <a:solidFill>
@@ -466,7 +466,7 @@
                 <a:uFillTx/>
                 <a:latin typeface="Calibri"/>
               </a:rPr>
-              <a:t> </a:t>
+              <a:t>&lt;footer&gt;</a:t>
             </a:r>
             <a:endParaRPr lang="en-US" sz="1200" b="0" u="none" strike="noStrike">
               <a:solidFill>
@@ -537,7 +537,7 @@
                 <a:tab algn="l" pos="0"/>
               </a:tabLst>
             </a:pPr>
-            <a:fld id="{0A242D0A-D750-4190-9A8D-3C6C38CFB6D9}" type="slidenum">
+            <a:fld id="{BF641DBC-7BC8-4F37-AE58-FF60A4E7D765}" type="slidenum">
               <a:rPr lang="en-US" sz="1200" b="0" u="none" strike="noStrike">
                 <a:solidFill>
                   <a:schemeClr val="dk1">
@@ -548,7 +548,7 @@
                 <a:uFillTx/>
                 <a:latin typeface="Calibri"/>
               </a:rPr>
-              <a:t>2</a:t>
+              <a:t>&lt;number&gt;</a:t>
             </a:fld>
             <a:endParaRPr lang="en-US" sz="1200" b="0" u="none" strike="noStrike">
               <a:solidFill>
@@ -918,7 +918,7 @@
                 <a:uFillTx/>
                 <a:latin typeface="Calibri"/>
               </a:rPr>
-              <a:t> </a:t>
+              <a:t>&lt;date/time&gt;</a:t>
             </a:r>
             <a:endParaRPr lang="en-US" sz="1200" b="0" u="none" strike="noStrike">
               <a:solidFill>
@@ -1000,7 +1000,7 @@
                 <a:uFillTx/>
                 <a:latin typeface="Calibri"/>
               </a:rPr>
-              <a:t> </a:t>
+              <a:t>&lt;footer&gt;</a:t>
             </a:r>
             <a:endParaRPr lang="en-US" sz="1200" b="0" u="none" strike="noStrike">
               <a:solidFill>
@@ -1071,7 +1071,7 @@
                 <a:tab algn="l" pos="0"/>
               </a:tabLst>
             </a:pPr>
-            <a:fld id="{4184B9A0-697A-4EDD-ADA1-6C39468C15FB}" type="slidenum">
+            <a:fld id="{7796EF2C-2C03-49AD-B7F2-1DE275574374}" type="slidenum">
               <a:rPr lang="en-US" sz="1200" b="0" u="none" strike="noStrike">
                 <a:solidFill>
                   <a:schemeClr val="dk1">
@@ -1082,7 +1082,7 @@
                 <a:uFillTx/>
                 <a:latin typeface="Calibri"/>
               </a:rPr>
-              <a:t>2</a:t>
+              <a:t>&lt;number&gt;</a:t>
             </a:fld>
             <a:endParaRPr lang="en-US" sz="1200" b="0" u="none" strike="noStrike">
               <a:solidFill>
@@ -1452,7 +1452,7 @@
                 <a:uFillTx/>
                 <a:latin typeface="Calibri"/>
               </a:rPr>
-              <a:t> </a:t>
+              <a:t>&lt;date/time&gt;</a:t>
             </a:r>
             <a:endParaRPr lang="en-US" sz="1200" b="0" u="none" strike="noStrike">
               <a:solidFill>
@@ -1534,7 +1534,7 @@
                 <a:uFillTx/>
                 <a:latin typeface="Calibri"/>
               </a:rPr>
-              <a:t> </a:t>
+              <a:t>&lt;footer&gt;</a:t>
             </a:r>
             <a:endParaRPr lang="en-US" sz="1200" b="0" u="none" strike="noStrike">
               <a:solidFill>
@@ -1605,7 +1605,7 @@
                 <a:tab algn="l" pos="0"/>
               </a:tabLst>
             </a:pPr>
-            <a:fld id="{12F614A1-9558-4295-A2AB-C33F9471F4B2}" type="slidenum">
+            <a:fld id="{8B668DCF-027B-4415-99A8-D87C73965770}" type="slidenum">
               <a:rPr lang="en-US" sz="1200" b="0" u="none" strike="noStrike">
                 <a:solidFill>
                   <a:schemeClr val="dk1">
@@ -1616,7 +1616,7 @@
                 <a:uFillTx/>
                 <a:latin typeface="Calibri"/>
               </a:rPr>
-              <a:t>2</a:t>
+              <a:t>&lt;number&gt;</a:t>
             </a:fld>
             <a:endParaRPr lang="en-US" sz="1200" b="0" u="none" strike="noStrike">
               <a:solidFill>
@@ -1787,7 +1787,7 @@
                 <a:uFillTx/>
                 <a:latin typeface="Calibri"/>
               </a:rPr>
-              <a:t> </a:t>
+              <a:t>&lt;footer&gt;</a:t>
             </a:r>
             <a:endParaRPr lang="en-US" sz="1200" b="0" u="none" strike="noStrike">
               <a:solidFill>
@@ -1858,7 +1858,7 @@
                 <a:tab algn="l" pos="0"/>
               </a:tabLst>
             </a:pPr>
-            <a:fld id="{F0543D24-D46A-4F26-ACB7-8A71E8EDD81B}" type="slidenum">
+            <a:fld id="{A45EE3C6-EF2D-4839-A16C-082A63E1E33B}" type="slidenum">
               <a:rPr lang="en-US" sz="1200" b="0" u="none" strike="noStrike">
                 <a:solidFill>
                   <a:schemeClr val="dk1">
@@ -1869,7 +1869,7 @@
                 <a:uFillTx/>
                 <a:latin typeface="Calibri"/>
               </a:rPr>
-              <a:t>2</a:t>
+              <a:t>&lt;number&gt;</a:t>
             </a:fld>
             <a:endParaRPr lang="en-US" sz="1200" b="0" u="none" strike="noStrike">
               <a:solidFill>
@@ -1947,7 +1947,7 @@
                 <a:uFillTx/>
                 <a:latin typeface="Times New Roman"/>
               </a:rPr>
-              <a:t> </a:t>
+              <a:t>&lt;date/time&gt;</a:t>
             </a:r>
             <a:endParaRPr lang="en-US" sz="1400" b="0" u="none" strike="noStrike">
               <a:solidFill>
@@ -2456,7 +2456,7 @@
                 <a:uFillTx/>
                 <a:latin typeface="Calibri"/>
               </a:rPr>
-              <a:t> </a:t>
+              <a:t>&lt;date/time&gt;</a:t>
             </a:r>
             <a:endParaRPr lang="en-US" sz="1200" b="0" u="none" strike="noStrike">
               <a:solidFill>
@@ -2538,7 +2538,7 @@
                 <a:uFillTx/>
                 <a:latin typeface="Calibri"/>
               </a:rPr>
-              <a:t> </a:t>
+              <a:t>&lt;footer&gt;</a:t>
             </a:r>
             <a:endParaRPr lang="en-US" sz="1200" b="0" u="none" strike="noStrike">
               <a:solidFill>
@@ -2609,7 +2609,7 @@
                 <a:tab algn="l" pos="0"/>
               </a:tabLst>
             </a:pPr>
-            <a:fld id="{FA72987C-1FB2-438C-95CB-75E3483AE4BA}" type="slidenum">
+            <a:fld id="{9882B631-FCD6-493F-B69C-DA98AEE8946F}" type="slidenum">
               <a:rPr lang="en-US" sz="1200" b="0" u="none" strike="noStrike">
                 <a:solidFill>
                   <a:schemeClr val="dk1">
@@ -2620,7 +2620,7 @@
                 <a:uFillTx/>
                 <a:latin typeface="Calibri"/>
               </a:rPr>
-              <a:t>2</a:t>
+              <a:t>&lt;number&gt;</a:t>
             </a:fld>
             <a:endParaRPr lang="en-US" sz="1200" b="0" u="none" strike="noStrike">
               <a:solidFill>
@@ -3189,7 +3189,7 @@
                 <a:uFillTx/>
                 <a:latin typeface="Calibri"/>
               </a:rPr>
-              <a:t> </a:t>
+              <a:t>&lt;date/time&gt;</a:t>
             </a:r>
             <a:endParaRPr lang="en-US" sz="1200" b="0" u="none" strike="noStrike">
               <a:solidFill>
@@ -3271,7 +3271,7 @@
                 <a:uFillTx/>
                 <a:latin typeface="Calibri"/>
               </a:rPr>
-              <a:t> </a:t>
+              <a:t>&lt;footer&gt;</a:t>
             </a:r>
             <a:endParaRPr lang="en-US" sz="1200" b="0" u="none" strike="noStrike">
               <a:solidFill>
@@ -3342,7 +3342,7 @@
                 <a:tab algn="l" pos="0"/>
               </a:tabLst>
             </a:pPr>
-            <a:fld id="{FEB9999D-2434-412B-85A4-2ADE5CEF5DF8}" type="slidenum">
+            <a:fld id="{6878CBF2-BAD6-4240-A76C-97661CDC0871}" type="slidenum">
               <a:rPr lang="en-US" sz="1200" b="0" u="none" strike="noStrike">
                 <a:solidFill>
                   <a:schemeClr val="dk1">
@@ -3353,7 +3353,7 @@
                 <a:uFillTx/>
                 <a:latin typeface="Calibri"/>
               </a:rPr>
-              <a:t>2</a:t>
+              <a:t>&lt;number&gt;</a:t>
             </a:fld>
             <a:endParaRPr lang="en-US" sz="1200" b="0" u="none" strike="noStrike">
               <a:solidFill>
@@ -4046,7 +4046,7 @@
                 <a:uFillTx/>
                 <a:latin typeface="Calibri"/>
               </a:rPr>
-              <a:t> </a:t>
+              <a:t>&lt;date/time&gt;</a:t>
             </a:r>
             <a:endParaRPr lang="en-US" sz="1200" b="0" u="none" strike="noStrike">
               <a:solidFill>
@@ -4128,7 +4128,7 @@
                 <a:uFillTx/>
                 <a:latin typeface="Calibri"/>
               </a:rPr>
-              <a:t> </a:t>
+              <a:t>&lt;footer&gt;</a:t>
             </a:r>
             <a:endParaRPr lang="en-US" sz="1200" b="0" u="none" strike="noStrike">
               <a:solidFill>
@@ -4199,7 +4199,7 @@
                 <a:tab algn="l" pos="0"/>
               </a:tabLst>
             </a:pPr>
-            <a:fld id="{BC09E7AC-4781-4130-A8AB-AF0A1BAEF1E5}" type="slidenum">
+            <a:fld id="{DE0833C8-701A-4AD1-A05B-E36B18983712}" type="slidenum">
               <a:rPr lang="en-US" sz="1200" b="0" u="none" strike="noStrike">
                 <a:solidFill>
                   <a:schemeClr val="dk1">
@@ -4210,7 +4210,7 @@
                 <a:uFillTx/>
                 <a:latin typeface="Calibri"/>
               </a:rPr>
-              <a:t>2</a:t>
+              <a:t>&lt;number&gt;</a:t>
             </a:fld>
             <a:endParaRPr lang="en-US" sz="1200" b="0" u="none" strike="noStrike">
               <a:solidFill>
@@ -4381,7 +4381,7 @@
                 <a:uFillTx/>
                 <a:latin typeface="Calibri"/>
               </a:rPr>
-              <a:t> </a:t>
+              <a:t>&lt;date/time&gt;</a:t>
             </a:r>
             <a:endParaRPr lang="en-US" sz="1200" b="0" u="none" strike="noStrike">
               <a:solidFill>
@@ -4463,7 +4463,7 @@
                 <a:uFillTx/>
                 <a:latin typeface="Calibri"/>
               </a:rPr>
-              <a:t> </a:t>
+              <a:t>&lt;footer&gt;</a:t>
             </a:r>
             <a:endParaRPr lang="en-US" sz="1200" b="0" u="none" strike="noStrike">
               <a:solidFill>
@@ -4534,7 +4534,7 @@
                 <a:tab algn="l" pos="0"/>
               </a:tabLst>
             </a:pPr>
-            <a:fld id="{D5A937FD-71A7-4085-BB62-4B3626613950}" type="slidenum">
+            <a:fld id="{EF470466-6A5C-4824-A6E8-B9EAD8CD222D}" type="slidenum">
               <a:rPr lang="en-US" sz="1200" b="0" u="none" strike="noStrike">
                 <a:solidFill>
                   <a:schemeClr val="dk1">
@@ -4545,7 +4545,7 @@
                 <a:uFillTx/>
                 <a:latin typeface="Calibri"/>
               </a:rPr>
-              <a:t>2</a:t>
+              <a:t>&lt;number&gt;</a:t>
             </a:fld>
             <a:endParaRPr lang="en-US" sz="1200" b="0" u="none" strike="noStrike">
               <a:solidFill>
@@ -4657,7 +4657,7 @@
                 <a:uFillTx/>
                 <a:latin typeface="Calibri"/>
               </a:rPr>
-              <a:t> </a:t>
+              <a:t>&lt;date/time&gt;</a:t>
             </a:r>
             <a:endParaRPr lang="en-US" sz="1200" b="0" u="none" strike="noStrike">
               <a:solidFill>
@@ -4739,7 +4739,7 @@
                 <a:uFillTx/>
                 <a:latin typeface="Calibri"/>
               </a:rPr>
-              <a:t> </a:t>
+              <a:t>&lt;footer&gt;</a:t>
             </a:r>
             <a:endParaRPr lang="en-US" sz="1200" b="0" u="none" strike="noStrike">
               <a:solidFill>
@@ -4810,7 +4810,7 @@
                 <a:tab algn="l" pos="0"/>
               </a:tabLst>
             </a:pPr>
-            <a:fld id="{67119220-6784-45F2-8F63-27629CB88B58}" type="slidenum">
+            <a:fld id="{66C8B2B3-1958-45EF-896D-6908F84193BC}" type="slidenum">
               <a:rPr lang="en-US" sz="1200" b="0" u="none" strike="noStrike">
                 <a:solidFill>
                   <a:schemeClr val="dk1">
@@ -4821,7 +4821,7 @@
                 <a:uFillTx/>
                 <a:latin typeface="Calibri"/>
               </a:rPr>
-              <a:t>2</a:t>
+              <a:t>&lt;number&gt;</a:t>
             </a:fld>
             <a:endParaRPr lang="en-US" sz="1200" b="0" u="none" strike="noStrike">
               <a:solidFill>
@@ -5253,7 +5253,7 @@
                 <a:uFillTx/>
                 <a:latin typeface="Calibri"/>
               </a:rPr>
-              <a:t> </a:t>
+              <a:t>&lt;date/time&gt;</a:t>
             </a:r>
             <a:endParaRPr lang="en-US" sz="1200" b="0" u="none" strike="noStrike">
               <a:solidFill>
@@ -5335,7 +5335,7 @@
                 <a:uFillTx/>
                 <a:latin typeface="Calibri"/>
               </a:rPr>
-              <a:t> </a:t>
+              <a:t>&lt;footer&gt;</a:t>
             </a:r>
             <a:endParaRPr lang="en-US" sz="1200" b="0" u="none" strike="noStrike">
               <a:solidFill>
@@ -5406,7 +5406,7 @@
                 <a:tab algn="l" pos="0"/>
               </a:tabLst>
             </a:pPr>
-            <a:fld id="{A59AB15B-025B-4C5E-99B0-06090A7C6736}" type="slidenum">
+            <a:fld id="{4CD72628-4120-46EB-A360-03D5619FD94B}" type="slidenum">
               <a:rPr lang="en-US" sz="1200" b="0" u="none" strike="noStrike">
                 <a:solidFill>
                   <a:schemeClr val="dk1">
@@ -5417,7 +5417,7 @@
                 <a:uFillTx/>
                 <a:latin typeface="Calibri"/>
               </a:rPr>
-              <a:t>2</a:t>
+              <a:t>&lt;number&gt;</a:t>
             </a:fld>
             <a:endParaRPr lang="en-US" sz="1200" b="0" u="none" strike="noStrike">
               <a:solidFill>
@@ -5709,7 +5709,7 @@
                 <a:uFillTx/>
                 <a:latin typeface="Calibri"/>
               </a:rPr>
-              <a:t> </a:t>
+              <a:t>&lt;date/time&gt;</a:t>
             </a:r>
             <a:endParaRPr lang="en-US" sz="1200" b="0" u="none" strike="noStrike">
               <a:solidFill>
@@ -5791,7 +5791,7 @@
                 <a:uFillTx/>
                 <a:latin typeface="Calibri"/>
               </a:rPr>
-              <a:t> </a:t>
+              <a:t>&lt;footer&gt;</a:t>
             </a:r>
             <a:endParaRPr lang="en-US" sz="1200" b="0" u="none" strike="noStrike">
               <a:solidFill>
@@ -5862,7 +5862,7 @@
                 <a:tab algn="l" pos="0"/>
               </a:tabLst>
             </a:pPr>
-            <a:fld id="{40F99376-45D2-43B3-BDA9-919B3FFD22D1}" type="slidenum">
+            <a:fld id="{4D3C702D-3480-479A-86D0-4F1FA1F1E266}" type="slidenum">
               <a:rPr lang="en-US" sz="1200" b="0" u="none" strike="noStrike">
                 <a:solidFill>
                   <a:schemeClr val="dk1">
@@ -5873,7 +5873,7 @@
                 <a:uFillTx/>
                 <a:latin typeface="Calibri"/>
               </a:rPr>
-              <a:t>2</a:t>
+              <a:t>&lt;number&gt;</a:t>
             </a:fld>
             <a:endParaRPr lang="en-US" sz="1200" b="0" u="none" strike="noStrike">
               <a:solidFill>
@@ -6044,7 +6044,7 @@
                 <a:uFillTx/>
                 <a:latin typeface="Calibri"/>
               </a:rPr>
-              <a:t> </a:t>
+              <a:t>&lt;date/time&gt;</a:t>
             </a:r>
             <a:endParaRPr lang="en-US" sz="1200" b="0" u="none" strike="noStrike">
               <a:solidFill>
@@ -6126,7 +6126,7 @@
                 <a:uFillTx/>
                 <a:latin typeface="Calibri"/>
               </a:rPr>
-              <a:t> </a:t>
+              <a:t>&lt;footer&gt;</a:t>
             </a:r>
             <a:endParaRPr lang="en-US" sz="1200" b="0" u="none" strike="noStrike">
               <a:solidFill>
@@ -6197,7 +6197,7 @@
                 <a:tab algn="l" pos="0"/>
               </a:tabLst>
             </a:pPr>
-            <a:fld id="{12FED4E2-9E29-422E-932B-C48F1DDB62D6}" type="slidenum">
+            <a:fld id="{5A92534A-2AC9-4A79-A0F6-0F91990EA5C8}" type="slidenum">
               <a:rPr lang="en-US" sz="1200" b="0" u="none" strike="noStrike">
                 <a:solidFill>
                   <a:schemeClr val="dk1">
@@ -6208,7 +6208,7 @@
                 <a:uFillTx/>
                 <a:latin typeface="Calibri"/>
               </a:rPr>
-              <a:t>2</a:t>
+              <a:t>&lt;number&gt;</a:t>
             </a:fld>
             <a:endParaRPr lang="en-US" sz="1200" b="0" u="none" strike="noStrike">
               <a:solidFill>
@@ -6550,8 +6550,8 @@
         </p:nvSpPr>
         <p:spPr>
           <a:xfrm>
-            <a:off x="504000" y="1600200"/>
-            <a:ext cx="10468440" cy="4114440"/>
+            <a:off x="457200" y="1231560"/>
+            <a:ext cx="10468440" cy="5397840"/>
           </a:xfrm>
           <a:prstGeom prst="rect">
             <a:avLst/>
@@ -6566,6 +6566,36 @@
             <a:noAutofit/>
           </a:bodyPr>
           <a:p>
+            <a:pPr indent="0" defTabSz="914400">
+              <a:lnSpc>
+                <a:spcPct val="90000"/>
+              </a:lnSpc>
+              <a:spcBef>
+                <a:spcPts val="1001"/>
+              </a:spcBef>
+              <a:buNone/>
+            </a:pPr>
+            <a:r>
+              <a:rPr lang="en-US" sz="2800" b="0" u="none" strike="noStrike">
+                <a:solidFill>
+                  <a:schemeClr val="dk1"/>
+                </a:solidFill>
+                <a:effectLst/>
+                <a:uFillTx/>
+                <a:latin typeface="Calibri"/>
+              </a:rPr>
+              <a:t>We have various scripts for controlling the environment as well as running the app. We have scripts for:</a:t>
+            </a:r>
+            <a:endParaRPr lang="en-US" sz="2800" b="0" u="none" strike="noStrike">
+              <a:solidFill>
+                <a:srgbClr val="000000"/>
+              </a:solidFill>
+              <a:effectLst/>
+              <a:uFillTx/>
+              <a:latin typeface="Arial"/>
+            </a:endParaRPr>
+          </a:p>
+          <a:p>
             <a:pPr marL="228600" indent="-228600" defTabSz="914400">
               <a:lnSpc>
                 <a:spcPct val="90000"/>
@@ -6588,7 +6618,207 @@
                 <a:uFillTx/>
                 <a:latin typeface="Calibri"/>
               </a:rPr>
-              <a:t>Maybe screenshots and how the bash files and linux line code is used</a:t>
+              <a:t>Backing up logs,</a:t>
+            </a:r>
+            <a:endParaRPr lang="en-US" sz="2800" b="0" u="none" strike="noStrike">
+              <a:solidFill>
+                <a:srgbClr val="000000"/>
+              </a:solidFill>
+              <a:effectLst/>
+              <a:uFillTx/>
+              <a:latin typeface="Arial"/>
+            </a:endParaRPr>
+          </a:p>
+          <a:p>
+            <a:pPr marL="228600" indent="-228600" defTabSz="914400">
+              <a:lnSpc>
+                <a:spcPct val="90000"/>
+              </a:lnSpc>
+              <a:spcBef>
+                <a:spcPts val="1001"/>
+              </a:spcBef>
+              <a:buClr>
+                <a:srgbClr val="000000"/>
+              </a:buClr>
+              <a:buFont typeface="Arial"/>
+              <a:buChar char="•"/>
+            </a:pPr>
+            <a:r>
+              <a:rPr lang="en-US" sz="2800" b="0" u="none" strike="noStrike">
+                <a:solidFill>
+                  <a:schemeClr val="dk1"/>
+                </a:solidFill>
+                <a:effectLst/>
+                <a:uFillTx/>
+                <a:latin typeface="Calibri"/>
+              </a:rPr>
+              <a:t>Running the app,</a:t>
+            </a:r>
+            <a:endParaRPr lang="en-US" sz="2800" b="0" u="none" strike="noStrike">
+              <a:solidFill>
+                <a:srgbClr val="000000"/>
+              </a:solidFill>
+              <a:effectLst/>
+              <a:uFillTx/>
+              <a:latin typeface="Arial"/>
+            </a:endParaRPr>
+          </a:p>
+          <a:p>
+            <a:pPr marL="228600" indent="-228600" defTabSz="914400">
+              <a:lnSpc>
+                <a:spcPct val="90000"/>
+              </a:lnSpc>
+              <a:spcBef>
+                <a:spcPts val="1001"/>
+              </a:spcBef>
+              <a:buClr>
+                <a:srgbClr val="000000"/>
+              </a:buClr>
+              <a:buFont typeface="Arial"/>
+              <a:buChar char="•"/>
+            </a:pPr>
+            <a:r>
+              <a:rPr lang="en-US" sz="2800" b="0" u="none" strike="noStrike">
+                <a:solidFill>
+                  <a:schemeClr val="dk1"/>
+                </a:solidFill>
+                <a:effectLst/>
+                <a:uFillTx/>
+                <a:latin typeface="Calibri"/>
+              </a:rPr>
+              <a:t>Running the tests,</a:t>
+            </a:r>
+            <a:endParaRPr lang="en-US" sz="2800" b="0" u="none" strike="noStrike">
+              <a:solidFill>
+                <a:srgbClr val="000000"/>
+              </a:solidFill>
+              <a:effectLst/>
+              <a:uFillTx/>
+              <a:latin typeface="Arial"/>
+            </a:endParaRPr>
+          </a:p>
+          <a:p>
+            <a:pPr marL="228600" indent="-228600" defTabSz="914400">
+              <a:lnSpc>
+                <a:spcPct val="90000"/>
+              </a:lnSpc>
+              <a:spcBef>
+                <a:spcPts val="1001"/>
+              </a:spcBef>
+              <a:buClr>
+                <a:srgbClr val="000000"/>
+              </a:buClr>
+              <a:buFont typeface="Arial"/>
+              <a:buChar char="•"/>
+            </a:pPr>
+            <a:r>
+              <a:rPr lang="en-US" sz="2800" b="0" u="none" strike="noStrike">
+                <a:solidFill>
+                  <a:schemeClr val="dk1"/>
+                </a:solidFill>
+                <a:effectLst/>
+                <a:uFillTx/>
+                <a:latin typeface="Calibri"/>
+              </a:rPr>
+              <a:t>Building the app,</a:t>
+            </a:r>
+            <a:endParaRPr lang="en-US" sz="2800" b="0" u="none" strike="noStrike">
+              <a:solidFill>
+                <a:srgbClr val="000000"/>
+              </a:solidFill>
+              <a:effectLst/>
+              <a:uFillTx/>
+              <a:latin typeface="Arial"/>
+            </a:endParaRPr>
+          </a:p>
+          <a:p>
+            <a:pPr marL="228600" indent="-228600" defTabSz="914400">
+              <a:lnSpc>
+                <a:spcPct val="90000"/>
+              </a:lnSpc>
+              <a:spcBef>
+                <a:spcPts val="1001"/>
+              </a:spcBef>
+              <a:buClr>
+                <a:srgbClr val="000000"/>
+              </a:buClr>
+              <a:buFont typeface="Arial"/>
+              <a:buChar char="•"/>
+            </a:pPr>
+            <a:r>
+              <a:rPr lang="en-US" sz="2800" b="0" u="none" strike="noStrike">
+                <a:solidFill>
+                  <a:schemeClr val="dk1"/>
+                </a:solidFill>
+                <a:effectLst/>
+                <a:uFillTx/>
+                <a:latin typeface="Calibri"/>
+              </a:rPr>
+              <a:t>Initializing the database and</a:t>
+            </a:r>
+            <a:endParaRPr lang="en-US" sz="2800" b="0" u="none" strike="noStrike">
+              <a:solidFill>
+                <a:srgbClr val="000000"/>
+              </a:solidFill>
+              <a:effectLst/>
+              <a:uFillTx/>
+              <a:latin typeface="Arial"/>
+            </a:endParaRPr>
+          </a:p>
+          <a:p>
+            <a:pPr marL="228600" indent="-228600" defTabSz="914400">
+              <a:lnSpc>
+                <a:spcPct val="90000"/>
+              </a:lnSpc>
+              <a:spcBef>
+                <a:spcPts val="1001"/>
+              </a:spcBef>
+              <a:buClr>
+                <a:srgbClr val="000000"/>
+              </a:buClr>
+              <a:buFont typeface="Arial"/>
+              <a:buChar char="•"/>
+            </a:pPr>
+            <a:r>
+              <a:rPr lang="en-US" sz="2800" b="0" u="none" strike="noStrike">
+                <a:solidFill>
+                  <a:schemeClr val="dk1"/>
+                </a:solidFill>
+                <a:effectLst/>
+                <a:uFillTx/>
+                <a:latin typeface="Calibri"/>
+              </a:rPr>
+              <a:t>Entering a docker environment as the app for testing purposes</a:t>
+            </a:r>
+            <a:endParaRPr lang="en-US" sz="2800" b="0" u="none" strike="noStrike">
+              <a:solidFill>
+                <a:srgbClr val="000000"/>
+              </a:solidFill>
+              <a:effectLst/>
+              <a:uFillTx/>
+              <a:latin typeface="Arial"/>
+            </a:endParaRPr>
+          </a:p>
+          <a:p>
+            <a:pPr indent="0" defTabSz="914400">
+              <a:lnSpc>
+                <a:spcPct val="90000"/>
+              </a:lnSpc>
+              <a:spcBef>
+                <a:spcPts val="1001"/>
+              </a:spcBef>
+              <a:buNone/>
+            </a:pPr>
+            <a:r>
+              <a:rPr lang="en-US" sz="2800" b="0" u="none" strike="noStrike">
+                <a:solidFill>
+                  <a:schemeClr val="dk1"/>
+                </a:solidFill>
+                <a:effectLst/>
+                <a:uFillTx/>
+                <a:latin typeface="Calibri"/>
+              </a:rPr>
+              <a:t>There are more scripts meant to be ran inside the container such as build and test scripts.</a:t>
             </a:r>
             <a:endParaRPr lang="en-US" sz="2800" b="0" u="none" strike="noStrike">
               <a:solidFill>
@@ -7377,8 +7607,8 @@
         </p:nvSpPr>
         <p:spPr>
           <a:xfrm>
-            <a:off x="504000" y="2776680"/>
-            <a:ext cx="9070560" cy="386640"/>
+            <a:off x="504000" y="1600200"/>
+            <a:ext cx="10926000" cy="4343400"/>
           </a:xfrm>
           <a:prstGeom prst="rect">
             <a:avLst/>
@@ -7393,18 +7623,14 @@
             <a:noAutofit/>
           </a:bodyPr>
           <a:p>
-            <a:pPr marL="228600" indent="-228600" defTabSz="914400">
+            <a:pPr indent="0" defTabSz="914400">
               <a:lnSpc>
                 <a:spcPct val="90000"/>
               </a:lnSpc>
               <a:spcBef>
                 <a:spcPts val="1001"/>
               </a:spcBef>
-              <a:buClr>
-                <a:srgbClr val="000000"/>
-              </a:buClr>
-              <a:buFont typeface="Arial"/>
-              <a:buChar char="•"/>
+              <a:buNone/>
             </a:pPr>
             <a:r>
               <a:rPr lang="en-US" sz="2800" b="0" u="none" strike="noStrike">
@@ -7415,7 +7641,7 @@
                 <a:uFillTx/>
                 <a:latin typeface="Calibri"/>
               </a:rPr>
-              <a:t>The testing we did and what we expectes vs what we got</a:t>
+              <a:t>We have created scripts that aid in the creation of a controlled environment for testing so that we can easily check differences from normal to abnormal behaviour.</a:t>
             </a:r>
             <a:endParaRPr lang="en-US" sz="2800" b="0" u="none" strike="noStrike">
               <a:solidFill>
@@ -7563,7 +7789,147 @@
                 <a:uFillTx/>
                 <a:latin typeface="Arial"/>
               </a:rPr>
-              <a:t>There were many challenges. Mainly</a:t>
+              <a:t>There were many challenges. Mainly:</a:t>
+            </a:r>
+            <a:endParaRPr lang="en-US" sz="3200" b="0" u="none" strike="noStrike">
+              <a:solidFill>
+                <a:srgbClr val="000000"/>
+              </a:solidFill>
+              <a:effectLst/>
+              <a:uFillTx/>
+              <a:latin typeface="Arial"/>
+            </a:endParaRPr>
+          </a:p>
+          <a:p>
+            <a:pPr marL="216000" indent="-216000">
+              <a:lnSpc>
+                <a:spcPct val="100000"/>
+              </a:lnSpc>
+              <a:buClr>
+                <a:srgbClr val="000000"/>
+              </a:buClr>
+              <a:buSzPct val="45000"/>
+              <a:buFont typeface="Wingdings" charset="2"/>
+              <a:buChar char=""/>
+              <a:tabLst>
+                <a:tab algn="l" pos="0"/>
+              </a:tabLst>
+            </a:pPr>
+            <a:r>
+              <a:rPr lang="en-US" sz="3200" b="0" u="none" strike="noStrike">
+                <a:solidFill>
+                  <a:srgbClr val="000000"/>
+                </a:solidFill>
+                <a:effectLst/>
+                <a:uFillTx/>
+                <a:latin typeface="Arial"/>
+              </a:rPr>
+              <a:t>The management and figuring out the structure as well as the database schema,</a:t>
+            </a:r>
+            <a:endParaRPr lang="en-US" sz="3200" b="0" u="none" strike="noStrike">
+              <a:solidFill>
+                <a:srgbClr val="000000"/>
+              </a:solidFill>
+              <a:effectLst/>
+              <a:uFillTx/>
+              <a:latin typeface="Arial"/>
+            </a:endParaRPr>
+          </a:p>
+          <a:p>
+            <a:pPr marL="216000" indent="-216000">
+              <a:lnSpc>
+                <a:spcPct val="100000"/>
+              </a:lnSpc>
+              <a:buClr>
+                <a:srgbClr val="000000"/>
+              </a:buClr>
+              <a:buSzPct val="45000"/>
+              <a:buFont typeface="Wingdings" charset="2"/>
+              <a:buChar char=""/>
+              <a:tabLst>
+                <a:tab algn="l" pos="0"/>
+              </a:tabLst>
+            </a:pPr>
+            <a:r>
+              <a:rPr lang="en-US" sz="3200" b="0" u="none" strike="noStrike">
+                <a:solidFill>
+                  <a:srgbClr val="000000"/>
+                </a:solidFill>
+                <a:effectLst/>
+                <a:uFillTx/>
+                <a:latin typeface="Arial"/>
+              </a:rPr>
+              <a:t>The class hierarchy and attributes of those classes,</a:t>
+            </a:r>
+            <a:endParaRPr lang="en-US" sz="3200" b="0" u="none" strike="noStrike">
+              <a:solidFill>
+                <a:srgbClr val="000000"/>
+              </a:solidFill>
+              <a:effectLst/>
+              <a:uFillTx/>
+              <a:latin typeface="Arial"/>
+            </a:endParaRPr>
+          </a:p>
+          <a:p>
+            <a:pPr marL="216000" indent="-216000">
+              <a:lnSpc>
+                <a:spcPct val="100000"/>
+              </a:lnSpc>
+              <a:buClr>
+                <a:srgbClr val="000000"/>
+              </a:buClr>
+              <a:buSzPct val="45000"/>
+              <a:buFont typeface="Wingdings" charset="2"/>
+              <a:buChar char=""/>
+              <a:tabLst>
+                <a:tab algn="l" pos="0"/>
+              </a:tabLst>
+            </a:pPr>
+            <a:r>
+              <a:rPr lang="en-US" sz="3200" b="0" u="none" strike="noStrike">
+                <a:solidFill>
+                  <a:srgbClr val="000000"/>
+                </a:solidFill>
+                <a:effectLst/>
+                <a:uFillTx/>
+                <a:latin typeface="Arial"/>
+              </a:rPr>
+              <a:t>Database trigger configuration,</a:t>
+            </a:r>
+            <a:endParaRPr lang="en-US" sz="3200" b="0" u="none" strike="noStrike">
+              <a:solidFill>
+                <a:srgbClr val="000000"/>
+              </a:solidFill>
+              <a:effectLst/>
+              <a:uFillTx/>
+              <a:latin typeface="Arial"/>
+            </a:endParaRPr>
+          </a:p>
+          <a:p>
+            <a:pPr marL="216000" indent="-216000">
+              <a:lnSpc>
+                <a:spcPct val="100000"/>
+              </a:lnSpc>
+              <a:buClr>
+                <a:srgbClr val="000000"/>
+              </a:buClr>
+              <a:buSzPct val="45000"/>
+              <a:buFont typeface="Wingdings" charset="2"/>
+              <a:buChar char=""/>
+              <a:tabLst>
+                <a:tab algn="l" pos="0"/>
+              </a:tabLst>
+            </a:pPr>
+            <a:r>
+              <a:rPr lang="en-US" sz="3200" b="0" u="none" strike="noStrike">
+                <a:solidFill>
+                  <a:srgbClr val="000000"/>
+                </a:solidFill>
+                <a:effectLst/>
+                <a:uFillTx/>
+                <a:latin typeface="Arial"/>
+              </a:rPr>
+              <a:t>Version control mistake management ect.</a:t>
             </a:r>
             <a:endParaRPr lang="en-US" sz="3200" b="0" u="none" strike="noStrike">
               <a:solidFill>
@@ -8081,8 +8447,8 @@
         </p:nvSpPr>
         <p:spPr>
           <a:xfrm>
-            <a:off x="504000" y="2776680"/>
-            <a:ext cx="9070560" cy="386640"/>
+            <a:off x="504000" y="1600200"/>
+            <a:ext cx="10468800" cy="4343400"/>
           </a:xfrm>
           <a:prstGeom prst="rect">
             <a:avLst/>
@@ -8118,7 +8484,7 @@
                 <a:uFillTx/>
                 <a:latin typeface="Calibri"/>
               </a:rPr>
-              <a:t>The things we can change and improve</a:t>
+              <a:t>A multi-toat order could be something a future version could use. A daemon-ful version as well.</a:t>
             </a:r>
             <a:endParaRPr lang="en-US" sz="2800" b="0" u="none" strike="noStrike">
               <a:solidFill>
@@ -9479,8 +9845,8 @@
         </p:nvSpPr>
         <p:spPr>
           <a:xfrm>
-            <a:off x="504000" y="2583000"/>
-            <a:ext cx="9070560" cy="774360"/>
+            <a:off x="504000" y="1371600"/>
+            <a:ext cx="10697400" cy="4343400"/>
           </a:xfrm>
           <a:prstGeom prst="rect">
             <a:avLst/>
@@ -9495,18 +9861,14 @@
             <a:noAutofit/>
           </a:bodyPr>
           <a:p>
-            <a:pPr marL="228600" indent="-228600" defTabSz="914400">
+            <a:pPr indent="0" defTabSz="914400">
               <a:lnSpc>
                 <a:spcPct val="90000"/>
               </a:lnSpc>
               <a:spcBef>
                 <a:spcPts val="1001"/>
               </a:spcBef>
-              <a:buClr>
-                <a:srgbClr val="000000"/>
-              </a:buClr>
-              <a:buFont typeface="Arial"/>
-              <a:buChar char="•"/>
+              <a:buNone/>
             </a:pPr>
             <a:r>
               <a:rPr lang="en-US" sz="2800" b="0" u="none" strike="noStrike">
@@ -9517,7 +9879,7 @@
                 <a:uFillTx/>
                 <a:latin typeface="Calibri"/>
               </a:rPr>
-              <a:t>The this that will take as granded like the storage is given ath restock is handled outside the system ect.</a:t>
+              <a:t>The system works with the basis of a simple daemonless WMS. It has one stock line as inventory since it simulates a simple warehouse. It keeps orders in-memory since they are not meant to be visible to the WCS and it selects products to be placed in toats. It only uses one toat per order.</a:t>
             </a:r>
             <a:endParaRPr lang="en-US" sz="2800" b="0" u="none" strike="noStrike">
               <a:solidFill>
@@ -9866,8 +10228,8 @@
         </p:nvSpPr>
         <p:spPr>
           <a:xfrm>
-            <a:off x="504000" y="1442520"/>
-            <a:ext cx="10925280" cy="4957560"/>
+            <a:off x="504000" y="1143000"/>
+            <a:ext cx="10925280" cy="5715000"/>
           </a:xfrm>
           <a:prstGeom prst="rect">
             <a:avLst/>
@@ -10273,6 +10635,54 @@
                 <a:latin typeface="Calibri"/>
               </a:rPr>
               <a:t> for C++ compilation.</a:t>
+            </a:r>
+            <a:endParaRPr lang="en-US" sz="2800" b="0" u="none" strike="noStrike">
+              <a:solidFill>
+                <a:srgbClr val="000000"/>
+              </a:solidFill>
+              <a:effectLst/>
+              <a:uFillTx/>
+              <a:latin typeface="Arial"/>
+            </a:endParaRPr>
+          </a:p>
+          <a:p>
+            <a:pPr marL="228600" indent="-228600" defTabSz="914400">
+              <a:lnSpc>
+                <a:spcPct val="90000"/>
+              </a:lnSpc>
+              <a:spcBef>
+                <a:spcPts val="1001"/>
+              </a:spcBef>
+              <a:buClr>
+                <a:srgbClr val="000000"/>
+              </a:buClr>
+              <a:buFont typeface="Arial"/>
+              <a:buChar char="•"/>
+              <a:tabLst>
+                <a:tab algn="l" pos="0"/>
+              </a:tabLst>
+            </a:pPr>
+            <a:r>
+              <a:rPr lang="en-US" sz="2800" b="1" u="none" strike="noStrike">
+                <a:solidFill>
+                  <a:schemeClr val="dk1"/>
+                </a:solidFill>
+                <a:effectLst/>
+                <a:uFillTx/>
+                <a:latin typeface="Calibri"/>
+              </a:rPr>
+              <a:t>Oracle SQL*PLUS</a:t>
+            </a:r>
+            <a:r>
+              <a:rPr lang="en-US" sz="2800" b="0" u="none" strike="noStrike">
+                <a:solidFill>
+                  <a:schemeClr val="dk1"/>
+                </a:solidFill>
+                <a:effectLst/>
+                <a:uFillTx/>
+                <a:latin typeface="Calibri"/>
+              </a:rPr>
+              <a:t> for database manipulation through scripting</a:t>
             </a:r>
             <a:endParaRPr lang="en-US" sz="2800" b="0" u="none" strike="noStrike">
               <a:solidFill>

</xml_diff>